<commit_message>
feat: migrate from localStorage to Firestore database
</commit_message>
<xml_diff>
--- a/The_Big_Classes_Presentation.pptx
+++ b/The_Big_Classes_Presentation.pptx
@@ -12,7 +12,6 @@
     <p:sldId id="260" r:id="rId11"/>
     <p:sldId id="261" r:id="rId12"/>
     <p:sldId id="262" r:id="rId13"/>
-    <p:sldId id="263" r:id="rId14"/>
   </p:sldIdLst>
   <p:sldSz cx="12191695" cy="6858000" type="screen4x3"/>
   <p:notesSz cx="6858000" cy="9144000"/>
@@ -3110,7 +3109,7 @@
             <a:avLst/>
           </a:prstGeom>
           <a:solidFill>
-            <a:srgbClr val="0B132B"/>
+            <a:srgbClr val="080D1A"/>
           </a:solidFill>
           <a:ln>
             <a:noFill/>
@@ -3140,23 +3139,90 @@
       </p:sp>
       <p:sp>
         <p:nvSpPr>
-          <p:cNvPr id="3" name="Oval 2"/>
+          <p:cNvPr id="3" name="TextBox 2"/>
+          <p:cNvSpPr txBox="1"/>
+          <p:nvPr/>
+        </p:nvSpPr>
+        <p:spPr>
+          <a:xfrm>
+            <a:off x="914400" y="1645920"/>
+            <a:ext cx="10332720" cy="2926080"/>
+          </a:xfrm>
+          <a:prstGeom prst="rect">
+            <a:avLst/>
+          </a:prstGeom>
+          <a:noFill/>
+        </p:spPr>
+        <p:txBody>
+          <a:bodyPr wrap="square">
+            <a:spAutoFit/>
+          </a:bodyPr>
+          <a:lstStyle/>
+          <a:p>
+            <a:pPr>
+              <a:spcAft>
+                <a:spcPts val="600"/>
+              </a:spcAft>
+              <a:defRPr sz="1100" b="1">
+                <a:solidFill>
+                  <a:srgbClr val="38BDF8"/>
+                </a:solidFill>
+              </a:defRPr>
+            </a:pPr>
+            <a:r>
+              <a:t>NEXT-GENERATION DUAL-PORTAL ACADEMIC SUITE</a:t>
+            </a:r>
+          </a:p>
+          <a:p>
+            <a:pPr>
+              <a:spcAft>
+                <a:spcPts val="800"/>
+              </a:spcAft>
+              <a:defRPr sz="4800" b="1">
+                <a:solidFill>
+                  <a:srgbClr val="FFFFFF"/>
+                </a:solidFill>
+              </a:defRPr>
+            </a:pPr>
+            <a:r>
+              <a:t>THE BIG CLASSES</a:t>
+            </a:r>
+          </a:p>
+          <a:p>
+            <a:pPr>
+              <a:defRPr sz="1400">
+                <a:solidFill>
+                  <a:srgbClr val="94A3B8"/>
+                </a:solidFill>
+              </a:defRPr>
+            </a:pPr>
+            <a:r>
+              <a:t>Unified AI Proctoring, Real-Time PIN Synchronization &amp; Anti-Cheating Assessment Desk</a:t>
+            </a:r>
+          </a:p>
+        </p:txBody>
+      </p:sp>
+      <p:sp>
+        <p:nvSpPr>
+          <p:cNvPr id="4" name="Rounded Rectangle 3"/>
           <p:cNvSpPr/>
           <p:nvPr/>
         </p:nvSpPr>
         <p:spPr>
           <a:xfrm>
-            <a:off x="914400" y="1371600"/>
-            <a:ext cx="731520" cy="731520"/>
-          </a:xfrm>
-          <a:prstGeom prst="ellipse">
+            <a:off x="914400" y="4846320"/>
+            <a:ext cx="3291840" cy="1371600"/>
+          </a:xfrm>
+          <a:prstGeom prst="roundRect">
             <a:avLst/>
           </a:prstGeom>
           <a:solidFill>
-            <a:srgbClr val="38BDF8"/>
+            <a:srgbClr val="111827"/>
           </a:solidFill>
-          <a:ln>
-            <a:noFill/>
+          <a:ln w="19050">
+            <a:solidFill>
+              <a:srgbClr val="2563EB"/>
+            </a:solidFill>
           </a:ln>
         </p:spPr>
         <p:style>
@@ -3174,80 +3240,40 @@
           </a:fontRef>
         </p:style>
         <p:txBody>
-          <a:bodyPr rtlCol="0" anchor="ctr"/>
+          <a:bodyPr rtlCol="0" anchor="ctr" wrap="square" lIns="228600" rIns="228600" tIns="228600"/>
           <a:lstStyle/>
           <a:p>
             <a:pPr algn="ctr">
-              <a:defRPr sz="1300" b="1">
-                <a:solidFill>
-                  <a:srgbClr val="0B132B"/>
-                </a:solidFill>
-              </a:defRPr>
-            </a:pPr>
-            <a:r>
-              <a:t>AI</a:t>
-            </a:r>
-          </a:p>
-        </p:txBody>
-      </p:sp>
-      <p:sp>
-        <p:nvSpPr>
-          <p:cNvPr id="4" name="TextBox 3"/>
-          <p:cNvSpPr txBox="1"/>
-          <p:nvPr/>
-        </p:nvSpPr>
-        <p:spPr>
-          <a:xfrm>
-            <a:off x="1828800" y="1280160"/>
-            <a:ext cx="9144000" cy="2743200"/>
-          </a:xfrm>
-          <a:prstGeom prst="rect">
-            <a:avLst/>
-          </a:prstGeom>
-          <a:noFill/>
-        </p:spPr>
-        <p:txBody>
-          <a:bodyPr wrap="square">
-            <a:spAutoFit/>
-          </a:bodyPr>
-          <a:lstStyle/>
-          <a:p>
-            <a:pPr>
-              <a:defRPr sz="1100" b="1">
-                <a:solidFill>
-                  <a:srgbClr val="38BDF8"/>
-                </a:solidFill>
-              </a:defRPr>
-            </a:pPr>
-            <a:r>
-              <a:t>NEXT-GENERATION EXAMINATION &amp; ASSESSMENT SUITE</a:t>
-            </a:r>
-          </a:p>
-          <a:p>
-            <a:pPr>
               <a:spcAft>
                 <a:spcPts val="600"/>
               </a:spcAft>
-              <a:defRPr sz="5000" b="1">
-                <a:solidFill>
-                  <a:srgbClr val="FFFFFF"/>
+              <a:defRPr sz="1300" b="1">
+                <a:solidFill>
+                  <a:srgbClr val="38BDF8"/>
                 </a:solidFill>
               </a:defRPr>
             </a:pPr>
             <a:r>
-              <a:t>THE BIG CLASSES</a:t>
+              <a:t>PROJECT LEAD</a:t>
             </a:r>
           </a:p>
           <a:p>
             <a:pPr>
-              <a:defRPr sz="1400">
+              <a:lnSpc>
+                <a:spcPct val="120000"/>
+              </a:lnSpc>
+              <a:defRPr sz="1050">
                 <a:solidFill>
                   <a:srgbClr val="94A3B8"/>
                 </a:solidFill>
               </a:defRPr>
             </a:pPr>
             <a:r>
-              <a:t>Dual-Role Architecture with Live Proctored Exam Arenas &amp; Integrity Enforcement</a:t>
+              <a:t>Aman Verma</a:t>
+            </a:r>
+            <a:br/>
+            <a:r>
+              <a:t>Full-Stack Developer &amp; Architecture Lead</a:t>
             </a:r>
           </a:p>
         </p:txBody>
@@ -3260,18 +3286,18 @@
         </p:nvSpPr>
         <p:spPr>
           <a:xfrm>
-            <a:off x="914400" y="4754880"/>
-            <a:ext cx="3108960" cy="1371600"/>
+            <a:off x="4480560" y="4846320"/>
+            <a:ext cx="3291840" cy="1371600"/>
           </a:xfrm>
           <a:prstGeom prst="roundRect">
             <a:avLst/>
           </a:prstGeom>
           <a:solidFill>
-            <a:srgbClr val="1C2541"/>
+            <a:srgbClr val="111827"/>
           </a:solidFill>
           <a:ln w="19050">
             <a:solidFill>
-              <a:srgbClr val="4F46E5"/>
+              <a:srgbClr val="2563EB"/>
             </a:solidFill>
           </a:ln>
         </p:spPr>
@@ -3297,14 +3323,14 @@
               <a:spcAft>
                 <a:spcPts val="600"/>
               </a:spcAft>
-              <a:defRPr sz="1400" b="1">
+              <a:defRPr sz="1300" b="1">
                 <a:solidFill>
                   <a:srgbClr val="38BDF8"/>
                 </a:solidFill>
               </a:defRPr>
             </a:pPr>
             <a:r>
-              <a:t>STRICT INTEGRITY</a:t>
+              <a:t>INTEGRITY CORE</a:t>
             </a:r>
           </a:p>
           <a:p>
@@ -3312,18 +3338,18 @@
               <a:lnSpc>
                 <a:spcPct val="120000"/>
               </a:lnSpc>
-              <a:defRPr sz="1100">
+              <a:defRPr sz="1050">
                 <a:solidFill>
                   <a:srgbClr val="94A3B8"/>
                 </a:solidFill>
               </a:defRPr>
             </a:pPr>
             <a:r>
-              <a:t>3-Strike Automated Tab Detection</a:t>
-            </a:r>
-            <a:br/>
-            <a:r>
-              <a:t>Zero-Tolerance Cheating Policy</a:t>
+              <a:t>3-Strike Tab Switch Detection</a:t>
+            </a:r>
+            <a:br/>
+            <a:r>
+              <a:t>Single-Attempt Result Lock</a:t>
             </a:r>
           </a:p>
         </p:txBody>
@@ -3336,18 +3362,18 @@
         </p:nvSpPr>
         <p:spPr>
           <a:xfrm>
-            <a:off x="4389120" y="4754880"/>
-            <a:ext cx="3108960" cy="1371600"/>
+            <a:off x="8046720" y="4846320"/>
+            <a:ext cx="3200400" cy="1371600"/>
           </a:xfrm>
           <a:prstGeom prst="roundRect">
             <a:avLst/>
           </a:prstGeom>
           <a:solidFill>
-            <a:srgbClr val="1C2541"/>
+            <a:srgbClr val="111827"/>
           </a:solidFill>
           <a:ln w="19050">
             <a:solidFill>
-              <a:srgbClr val="38BDF8"/>
+              <a:srgbClr val="2563EB"/>
             </a:solidFill>
           </a:ln>
         </p:spPr>
@@ -3373,14 +3399,14 @@
               <a:spcAft>
                 <a:spcPts val="600"/>
               </a:spcAft>
-              <a:defRPr sz="1400" b="1">
+              <a:defRPr sz="1300" b="1">
                 <a:solidFill>
                   <a:srgbClr val="38BDF8"/>
                 </a:solidFill>
               </a:defRPr>
             </a:pPr>
             <a:r>
-              <a:t>FAST ACCESS</a:t>
+              <a:t>TECHNOLOGY</a:t>
             </a:r>
           </a:p>
           <a:p>
@@ -3388,94 +3414,18 @@
               <a:lnSpc>
                 <a:spcPct val="120000"/>
               </a:lnSpc>
-              <a:defRPr sz="1100">
+              <a:defRPr sz="1050">
                 <a:solidFill>
                   <a:srgbClr val="94A3B8"/>
                 </a:solidFill>
               </a:defRPr>
             </a:pPr>
             <a:r>
-              <a:t>6-Digit Sync Room PIN</a:t>
-            </a:r>
-            <a:br/>
-            <a:r>
-              <a:t>Instant Candidate Roster Connect</a:t>
-            </a:r>
-          </a:p>
-        </p:txBody>
-      </p:sp>
-      <p:sp>
-        <p:nvSpPr>
-          <p:cNvPr id="7" name="Rounded Rectangle 6"/>
-          <p:cNvSpPr/>
-          <p:nvPr/>
-        </p:nvSpPr>
-        <p:spPr>
-          <a:xfrm>
-            <a:off x="7863840" y="4754880"/>
-            <a:ext cx="3383280" cy="1371600"/>
-          </a:xfrm>
-          <a:prstGeom prst="roundRect">
-            <a:avLst/>
-          </a:prstGeom>
-          <a:solidFill>
-            <a:srgbClr val="1C2541"/>
-          </a:solidFill>
-          <a:ln w="19050">
-            <a:solidFill>
-              <a:srgbClr val="4F46E5"/>
-            </a:solidFill>
-          </a:ln>
-        </p:spPr>
-        <p:style>
-          <a:lnRef idx="1">
-            <a:schemeClr val="accent1"/>
-          </a:lnRef>
-          <a:fillRef idx="3">
-            <a:schemeClr val="accent1"/>
-          </a:fillRef>
-          <a:effectRef idx="2">
-            <a:schemeClr val="accent1"/>
-          </a:effectRef>
-          <a:fontRef idx="minor">
-            <a:schemeClr val="lt1"/>
-          </a:fontRef>
-        </p:style>
-        <p:txBody>
-          <a:bodyPr rtlCol="0" anchor="ctr" wrap="square" lIns="228600" rIns="228600" tIns="228600"/>
-          <a:lstStyle/>
-          <a:p>
-            <a:pPr algn="ctr">
-              <a:spcAft>
-                <a:spcPts val="600"/>
-              </a:spcAft>
-              <a:defRPr sz="1400" b="1">
-                <a:solidFill>
-                  <a:srgbClr val="38BDF8"/>
-                </a:solidFill>
-              </a:defRPr>
-            </a:pPr>
-            <a:r>
-              <a:t>ARCHITECTURE</a:t>
-            </a:r>
-          </a:p>
-          <a:p>
-            <a:pPr>
-              <a:lnSpc>
-                <a:spcPct val="120000"/>
-              </a:lnSpc>
-              <a:defRPr sz="1100">
-                <a:solidFill>
-                  <a:srgbClr val="94A3B8"/>
-                </a:solidFill>
-              </a:defRPr>
-            </a:pPr>
-            <a:r>
-              <a:t>Lead: Aman Verma</a:t>
-            </a:r>
-            <a:br/>
-            <a:r>
-              <a:t>Tech: React • TypeScript • Wouter</a:t>
+              <a:t>React 18 • TypeScript</a:t>
+            </a:r>
+            <a:br/>
+            <a:r>
+              <a:t>Vite • Tailwind • Wouter</a:t>
             </a:r>
           </a:p>
         </p:txBody>
@@ -3513,7 +3463,7 @@
             <a:avLst/>
           </a:prstGeom>
           <a:solidFill>
-            <a:srgbClr val="0B132B"/>
+            <a:srgbClr val="080D1A"/>
           </a:solidFill>
           <a:ln>
             <a:noFill/>
@@ -3574,19 +3524,19 @@
               </a:defRPr>
             </a:pPr>
             <a:r>
-              <a:t>PROBLEM / SOLUTION</a:t>
+              <a:t>PROBLEM &amp; SOLUTION</a:t>
             </a:r>
           </a:p>
           <a:p>
             <a:pPr>
-              <a:defRPr sz="2600" b="1">
+              <a:defRPr sz="2500" b="1">
                 <a:solidFill>
                   <a:srgbClr val="FFFFFF"/>
                 </a:solidFill>
               </a:defRPr>
             </a:pPr>
             <a:r>
-              <a:t>Modern Examination Pitfalls vs. The Big Classes Solution</a:t>
+              <a:t>Modern Examination Vulnerabilities vs The Big Classes</a:t>
             </a:r>
           </a:p>
         </p:txBody>
@@ -3606,11 +3556,11 @@
             <a:avLst/>
           </a:prstGeom>
           <a:solidFill>
-            <a:srgbClr val="1C2541"/>
+            <a:srgbClr val="111827"/>
           </a:solidFill>
           <a:ln w="19050">
             <a:solidFill>
-              <a:srgbClr val="F43F5E"/>
+              <a:srgbClr val="EF4444"/>
             </a:solidFill>
           </a:ln>
         </p:spPr>
@@ -3636,14 +3586,14 @@
               <a:spcAft>
                 <a:spcPts val="600"/>
               </a:spcAft>
-              <a:defRPr sz="1400" b="1">
+              <a:defRPr sz="1300" b="1">
                 <a:solidFill>
                   <a:srgbClr val="38BDF8"/>
                 </a:solidFill>
               </a:defRPr>
             </a:pPr>
             <a:r>
-              <a:t>THE TRADITIONAL ASSESSMENT GAP</a:t>
+              <a:t>THE TRADITIONAL ASSESSMENT PROBLEM</a:t>
             </a:r>
           </a:p>
           <a:p>
@@ -3651,24 +3601,29 @@
               <a:lnSpc>
                 <a:spcPct val="120000"/>
               </a:lnSpc>
-              <a:defRPr sz="1100">
+              <a:defRPr sz="1050">
                 <a:solidFill>
                   <a:srgbClr val="94A3B8"/>
                 </a:solidFill>
               </a:defRPr>
             </a:pPr>
             <a:r>
-              <a:t>• Vulnerable Testing: Unmonitored tabs encourage candidates to search answers in real-time.</a:t>
-            </a:r>
-            <a:br/>
-            <a:br/>
-            <a:r>
-              <a:t>• Disconnected Roles: Teachers and students use disparate tools requiring manual score compilation.</a:t>
-            </a:r>
-            <a:br/>
-            <a:br/>
-            <a:r>
-              <a:t>• Laggy Platforms: Bloated enterprise LMS frameworks introduce friction and high latency during active exams.</a:t>
+              <a:t>• Vulnerable Windows: Examinees easily switch tabs or browse solutions mid-test.</a:t>
+            </a:r>
+            <a:br/>
+            <a:br/>
+            <a:r>
+              <a:t>• Fragmented Systems: Faculty drafts questions in one app while students test on another, leading to manual sync overhead.</a:t>
+            </a:r>
+            <a:br/>
+            <a:br/>
+            <a:r>
+              <a:t>• Loopholes &amp; Retakes: Lack of strict submission locks allows students to retry and manipulate test scores.</a:t>
+            </a:r>
+            <a:br/>
+            <a:br/>
+            <a:r>
+              <a:t>• Cluttered Interfaces: Outdated LMS platforms cause cognitive distraction during timed exams.</a:t>
             </a:r>
           </a:p>
         </p:txBody>
@@ -3688,7 +3643,7 @@
             <a:avLst/>
           </a:prstGeom>
           <a:solidFill>
-            <a:srgbClr val="1C2541"/>
+            <a:srgbClr val="111827"/>
           </a:solidFill>
           <a:ln w="19050">
             <a:solidFill>
@@ -3718,14 +3673,14 @@
               <a:spcAft>
                 <a:spcPts val="600"/>
               </a:spcAft>
-              <a:defRPr sz="1400" b="1">
+              <a:defRPr sz="1300" b="1">
                 <a:solidFill>
                   <a:srgbClr val="38BDF8"/>
                 </a:solidFill>
               </a:defRPr>
             </a:pPr>
             <a:r>
-              <a:t>THE BIG CLASSES PARADIGM</a:t>
+              <a:t>THE BIG CLASSES SOLUTION</a:t>
             </a:r>
           </a:p>
           <a:p>
@@ -3733,24 +3688,29 @@
               <a:lnSpc>
                 <a:spcPct val="120000"/>
               </a:lnSpc>
-              <a:defRPr sz="1100">
+              <a:defRPr sz="1050">
                 <a:solidFill>
                   <a:srgbClr val="94A3B8"/>
                 </a:solidFill>
               </a:defRPr>
             </a:pPr>
             <a:r>
-              <a:t>• Proctored Browser Shield: Automatic visibility listeners penalize tab shifts instantly.</a:t>
-            </a:r>
-            <a:br/>
-            <a:br/>
-            <a:r>
-              <a:t>• Real-Time Room Binding: Faculty room PINs directly stream quizzes to verified student desks.</a:t>
-            </a:r>
-            <a:br/>
-            <a:br/>
-            <a:r>
-              <a:t>• Lightweight Dual Cockpit: Netflix-grade sleek dark UI optimized for distraction-free focus.</a:t>
+              <a:t>• Built-In Proctoring: Native Page Visibility listeners trigger immediate disciplinary strikes upon blur.</a:t>
+            </a:r>
+            <a:br/>
+            <a:br/>
+            <a:r>
+              <a:t>• 6-Digit PIN Synchronization: Unified room registry connects Faculty host directly with Student arena.</a:t>
+            </a:r>
+            <a:br/>
+            <a:br/>
+            <a:r>
+              <a:t>• Strict Single-Attempt Lock: Completed sessions permanently lock retakes and issue verified PDF scorecards.</a:t>
+            </a:r>
+            <a:br/>
+            <a:br/>
+            <a:r>
+              <a:t>• Netflix-Grade Dark Aesthetic: Clean, distraction-free environment with 100% pure white contrast.</a:t>
             </a:r>
           </a:p>
         </p:txBody>
@@ -3788,7 +3748,7 @@
             <a:avLst/>
           </a:prstGeom>
           <a:solidFill>
-            <a:srgbClr val="0B132B"/>
+            <a:srgbClr val="080D1A"/>
           </a:solidFill>
           <a:ln>
             <a:noFill/>
@@ -3849,19 +3809,19 @@
               </a:defRPr>
             </a:pPr>
             <a:r>
-              <a:t>TECH STACK MATRIX</a:t>
+              <a:t>TECHNICAL ARCHITECTURE</a:t>
             </a:r>
           </a:p>
           <a:p>
             <a:pPr>
-              <a:defRPr sz="2600" b="1">
+              <a:defRPr sz="2500" b="1">
                 <a:solidFill>
                   <a:srgbClr val="FFFFFF"/>
                 </a:solidFill>
               </a:defRPr>
             </a:pPr>
             <a:r>
-              <a:t>Engineered for Resilience, High Speed &amp; Type Safety</a:t>
+              <a:t>High-Performance Modular Tech Stack</a:t>
             </a:r>
           </a:p>
         </p:txBody>
@@ -3881,11 +3841,11 @@
             <a:avLst/>
           </a:prstGeom>
           <a:solidFill>
-            <a:srgbClr val="1C2541"/>
+            <a:srgbClr val="111827"/>
           </a:solidFill>
           <a:ln w="19050">
             <a:solidFill>
-              <a:srgbClr val="4F46E5"/>
+              <a:srgbClr val="2563EB"/>
             </a:solidFill>
           </a:ln>
         </p:spPr>
@@ -3911,14 +3871,14 @@
               <a:spcAft>
                 <a:spcPts val="600"/>
               </a:spcAft>
-              <a:defRPr sz="1400" b="1">
+              <a:defRPr sz="1300" b="1">
                 <a:solidFill>
                   <a:srgbClr val="38BDF8"/>
                 </a:solidFill>
               </a:defRPr>
             </a:pPr>
             <a:r>
-              <a:t>FRONTEND CORE</a:t>
+              <a:t>1. FRONTEND CORE</a:t>
             </a:r>
           </a:p>
           <a:p>
@@ -3926,26 +3886,29 @@
               <a:lnSpc>
                 <a:spcPct val="120000"/>
               </a:lnSpc>
-              <a:defRPr sz="1100">
+              <a:defRPr sz="1050">
                 <a:solidFill>
                   <a:srgbClr val="94A3B8"/>
                 </a:solidFill>
               </a:defRPr>
             </a:pPr>
             <a:r>
-              <a:t>• React 18 SPA</a:t>
-            </a:r>
-            <a:br/>
-            <a:r>
-              <a:t>• TypeScript Safety</a:t>
-            </a:r>
-            <a:br/>
-            <a:r>
-              <a:t>• Vite Engine</a:t>
-            </a:r>
-            <a:br/>
-            <a:r>
-              <a:t>• Wouter Routing</a:t>
+              <a:t>• React 18 SPA Framework</a:t>
+            </a:r>
+            <a:br/>
+            <a:br/>
+            <a:r>
+              <a:t>• TypeScript for strict types</a:t>
+            </a:r>
+            <a:br/>
+            <a:br/>
+            <a:r>
+              <a:t>• Vite Bundler for lightning-fast HMR builds</a:t>
+            </a:r>
+            <a:br/>
+            <a:br/>
+            <a:r>
+              <a:t>• Wouter for lightweight routing</a:t>
             </a:r>
           </a:p>
         </p:txBody>
@@ -3965,11 +3928,11 @@
             <a:avLst/>
           </a:prstGeom>
           <a:solidFill>
-            <a:srgbClr val="1C2541"/>
+            <a:srgbClr val="111827"/>
           </a:solidFill>
           <a:ln w="19050">
             <a:solidFill>
-              <a:srgbClr val="4F46E5"/>
+              <a:srgbClr val="2563EB"/>
             </a:solidFill>
           </a:ln>
         </p:spPr>
@@ -3995,14 +3958,14 @@
               <a:spcAft>
                 <a:spcPts val="600"/>
               </a:spcAft>
-              <a:defRPr sz="1400" b="1">
+              <a:defRPr sz="1300" b="1">
                 <a:solidFill>
                   <a:srgbClr val="38BDF8"/>
                 </a:solidFill>
               </a:defRPr>
             </a:pPr>
             <a:r>
-              <a:t>STATE &amp; COMM</a:t>
+              <a:t>2. STATE &amp; SYNC</a:t>
             </a:r>
           </a:p>
           <a:p>
@@ -4010,26 +3973,29 @@
               <a:lnSpc>
                 <a:spcPct val="120000"/>
               </a:lnSpc>
-              <a:defRPr sz="1100">
+              <a:defRPr sz="1050">
                 <a:solidFill>
                   <a:srgbClr val="94A3B8"/>
                 </a:solidFill>
               </a:defRPr>
             </a:pPr>
             <a:r>
-              <a:t>• TanStack React Query</a:t>
-            </a:r>
-            <a:br/>
-            <a:r>
-              <a:t>• Centralized AuthContext</a:t>
-            </a:r>
-            <a:br/>
-            <a:r>
-              <a:t>• LocalStorage Sync Bus</a:t>
-            </a:r>
-            <a:br/>
-            <a:r>
-              <a:t>• Visibility Detection API</a:t>
+              <a:t>• TanStack React Query for async caching</a:t>
+            </a:r>
+            <a:br/>
+            <a:br/>
+            <a:r>
+              <a:t>• Centralized AuthContext for role switching</a:t>
+            </a:r>
+            <a:br/>
+            <a:br/>
+            <a:r>
+              <a:t>• Synchronized Room Store (LocalStorage Bridge)</a:t>
+            </a:r>
+            <a:br/>
+            <a:br/>
+            <a:r>
+              <a:t>• Active Candidate Poller</a:t>
             </a:r>
           </a:p>
         </p:txBody>
@@ -4049,11 +4015,11 @@
             <a:avLst/>
           </a:prstGeom>
           <a:solidFill>
-            <a:srgbClr val="1C2541"/>
+            <a:srgbClr val="111827"/>
           </a:solidFill>
           <a:ln w="19050">
             <a:solidFill>
-              <a:srgbClr val="4F46E5"/>
+              <a:srgbClr val="2563EB"/>
             </a:solidFill>
           </a:ln>
         </p:spPr>
@@ -4079,14 +4045,14 @@
               <a:spcAft>
                 <a:spcPts val="600"/>
               </a:spcAft>
-              <a:defRPr sz="1400" b="1">
+              <a:defRPr sz="1300" b="1">
                 <a:solidFill>
                   <a:srgbClr val="38BDF8"/>
                 </a:solidFill>
               </a:defRPr>
             </a:pPr>
             <a:r>
-              <a:t>DOCUMENT AI</a:t>
+              <a:t>3. PROCTORING &amp; DOCS</a:t>
             </a:r>
           </a:p>
           <a:p>
@@ -4094,26 +4060,29 @@
               <a:lnSpc>
                 <a:spcPct val="120000"/>
               </a:lnSpc>
-              <a:defRPr sz="1100">
+              <a:defRPr sz="1050">
                 <a:solidFill>
                   <a:srgbClr val="94A3B8"/>
                 </a:solidFill>
               </a:defRPr>
             </a:pPr>
             <a:r>
-              <a:t>• PDF.js Document Worker</a:t>
-            </a:r>
-            <a:br/>
-            <a:r>
-              <a:t>• Ingestion Text Parser</a:t>
-            </a:r>
-            <a:br/>
-            <a:r>
-              <a:t>• CSV Candidate Exporter</a:t>
-            </a:r>
-            <a:br/>
-            <a:r>
-              <a:t>• Client PDF Certificate Engine</a:t>
+              <a:t>• HTML5 Page Visibility API (Cheating strikes)</a:t>
+            </a:r>
+            <a:br/>
+            <a:br/>
+            <a:r>
+              <a:t>• PDF.js Document Worker (Syllabus extraction)</a:t>
+            </a:r>
+            <a:br/>
+            <a:br/>
+            <a:r>
+              <a:t>• Dynamic HTML-to-Print Scorecard Engine</a:t>
+            </a:r>
+            <a:br/>
+            <a:br/>
+            <a:r>
+              <a:t>• CSV Ledger Exporter</a:t>
             </a:r>
           </a:p>
         </p:txBody>
@@ -4133,11 +4102,11 @@
             <a:avLst/>
           </a:prstGeom>
           <a:solidFill>
-            <a:srgbClr val="1C2541"/>
+            <a:srgbClr val="111827"/>
           </a:solidFill>
           <a:ln w="19050">
             <a:solidFill>
-              <a:srgbClr val="4F46E5"/>
+              <a:srgbClr val="2563EB"/>
             </a:solidFill>
           </a:ln>
         </p:spPr>
@@ -4163,14 +4132,14 @@
               <a:spcAft>
                 <a:spcPts val="600"/>
               </a:spcAft>
-              <a:defRPr sz="1400" b="1">
+              <a:defRPr sz="1300" b="1">
                 <a:solidFill>
                   <a:srgbClr val="38BDF8"/>
                 </a:solidFill>
               </a:defRPr>
             </a:pPr>
             <a:r>
-              <a:t>UI &amp; GRAPHICS</a:t>
+              <a:t>4. DESIGN SYSTEM</a:t>
             </a:r>
           </a:p>
           <a:p>
@@ -4178,26 +4147,29 @@
               <a:lnSpc>
                 <a:spcPct val="120000"/>
               </a:lnSpc>
-              <a:defRPr sz="1100">
+              <a:defRPr sz="1050">
                 <a:solidFill>
                   <a:srgbClr val="94A3B8"/>
                 </a:solidFill>
               </a:defRPr>
             </a:pPr>
             <a:r>
-              <a:t>• Tailwind CSS Engine</a:t>
-            </a:r>
-            <a:br/>
-            <a:r>
-              <a:t>• Lucide Vector Suite</a:t>
-            </a:r>
-            <a:br/>
-            <a:r>
-              <a:t>• High-Contrast Dark Theme</a:t>
-            </a:r>
-            <a:br/>
-            <a:r>
-              <a:t>• Custom Keyframe Flares</a:t>
+              <a:t>• Tailwind CSS Framework</a:t>
+            </a:r>
+            <a:br/>
+            <a:br/>
+            <a:r>
+              <a:t>• Pure Slate Background (#080D1A)</a:t>
+            </a:r>
+            <a:br/>
+            <a:br/>
+            <a:r>
+              <a:t>• Pure Crisp Font (#FFFFFF)</a:t>
+            </a:r>
+            <a:br/>
+            <a:br/>
+            <a:r>
+              <a:t>• Lucide React Icons</a:t>
             </a:r>
           </a:p>
         </p:txBody>
@@ -4235,7 +4207,7 @@
             <a:avLst/>
           </a:prstGeom>
           <a:solidFill>
-            <a:srgbClr val="0B132B"/>
+            <a:srgbClr val="080D1A"/>
           </a:solidFill>
           <a:ln>
             <a:noFill/>
@@ -4296,19 +4268,19 @@
               </a:defRPr>
             </a:pPr>
             <a:r>
-              <a:t>PORTAL ISOLATION</a:t>
+              <a:t>PORTAL MATRIX</a:t>
             </a:r>
           </a:p>
           <a:p>
             <a:pPr>
-              <a:defRPr sz="2600" b="1">
+              <a:defRPr sz="2500" b="1">
                 <a:solidFill>
                   <a:srgbClr val="FFFFFF"/>
                 </a:solidFill>
               </a:defRPr>
             </a:pPr>
             <a:r>
-              <a:t>Two Dedicated Workspaces. Zero Cross-Contamination.</a:t>
+              <a:t>Separation of Concerns: Dual Specialized Workspaces</a:t>
             </a:r>
           </a:p>
         </p:txBody>
@@ -4328,11 +4300,11 @@
             <a:avLst/>
           </a:prstGeom>
           <a:solidFill>
-            <a:srgbClr val="1C2541"/>
+            <a:srgbClr val="111827"/>
           </a:solidFill>
           <a:ln w="19050">
             <a:solidFill>
-              <a:srgbClr val="4F46E5"/>
+              <a:srgbClr val="2563EB"/>
             </a:solidFill>
           </a:ln>
         </p:spPr>
@@ -4358,7 +4330,7 @@
               <a:spcAft>
                 <a:spcPts val="600"/>
               </a:spcAft>
-              <a:defRPr sz="1400" b="1">
+              <a:defRPr sz="1300" b="1">
                 <a:solidFill>
                   <a:srgbClr val="38BDF8"/>
                 </a:solidFill>
@@ -4373,29 +4345,34 @@
               <a:lnSpc>
                 <a:spcPct val="120000"/>
               </a:lnSpc>
-              <a:defRPr sz="1100">
+              <a:defRPr sz="1050">
                 <a:solidFill>
                   <a:srgbClr val="94A3B8"/>
                 </a:solidFill>
               </a:defRPr>
             </a:pPr>
             <a:r>
-              <a:t>• AI Quiz Formulator: Transforms text &amp; PDF syllabi into timed tests.</a:t>
-            </a:r>
-            <a:br/>
-            <a:br/>
-            <a:r>
-              <a:t>• 6-Digit PIN Room Broadcast: One-click live room generation.</a:t>
-            </a:r>
-            <a:br/>
-            <a:br/>
-            <a:r>
-              <a:t>• Real-Time Candidate Tracker: Live tracking of examinee status.</a:t>
-            </a:r>
-            <a:br/>
-            <a:br/>
-            <a:r>
-              <a:t>• Scorecard Email Dispatch: Single-click mailto dispatch of results.</a:t>
+              <a:t>• AI Question Generation: Ingests raw text or uploaded PDF course material to formulate targeted MCQs.</a:t>
+            </a:r>
+            <a:br/>
+            <a:br/>
+            <a:r>
+              <a:t>• Room Token Host: Issues 6-digit access codes with duration and difficulty bounds.</a:t>
+            </a:r>
+            <a:br/>
+            <a:br/>
+            <a:r>
+              <a:t>• Live Monitoring Ledger: Tracks active examinees, ongoing attempts, and strike violations in real time.</a:t>
+            </a:r>
+            <a:br/>
+            <a:br/>
+            <a:r>
+              <a:t>• Scorecard Dispatch: Single-click email delivery of student evaluation reports and CSV ledger export.</a:t>
+            </a:r>
+            <a:br/>
+            <a:br/>
+            <a:r>
+              <a:t>• Academic Utilities: Integrated Lesson Planner, Assignment Creator, and Answer Grader.</a:t>
             </a:r>
           </a:p>
         </p:txBody>
@@ -4415,11 +4392,11 @@
             <a:avLst/>
           </a:prstGeom>
           <a:solidFill>
-            <a:srgbClr val="1C2541"/>
+            <a:srgbClr val="111827"/>
           </a:solidFill>
           <a:ln w="19050">
             <a:solidFill>
-              <a:srgbClr val="4F46E5"/>
+              <a:srgbClr val="2563EB"/>
             </a:solidFill>
           </a:ln>
         </p:spPr>
@@ -4445,14 +4422,14 @@
               <a:spcAft>
                 <a:spcPts val="600"/>
               </a:spcAft>
-              <a:defRPr sz="1400" b="1">
+              <a:defRPr sz="1300" b="1">
                 <a:solidFill>
                   <a:srgbClr val="38BDF8"/>
                 </a:solidFill>
               </a:defRPr>
             </a:pPr>
             <a:r>
-              <a:t>STUDENT EXAM ARENA</a:t>
+              <a:t>STUDENT EXAMINATION ARENA</a:t>
             </a:r>
           </a:p>
           <a:p>
@@ -4460,29 +4437,34 @@
               <a:lnSpc>
                 <a:spcPct val="120000"/>
               </a:lnSpc>
-              <a:defRPr sz="1100">
+              <a:defRPr sz="1050">
                 <a:solidFill>
                   <a:srgbClr val="94A3B8"/>
                 </a:solidFill>
               </a:defRPr>
             </a:pPr>
             <a:r>
-              <a:t>• Clean Token Entry: Quick start with Candidate Name, Email &amp; Room PIN.</a:t>
-            </a:r>
-            <a:br/>
-            <a:br/>
-            <a:r>
-              <a:t>• Synchronized Questions: Pulls active quiz generated by faculty.</a:t>
-            </a:r>
-            <a:br/>
-            <a:br/>
-            <a:r>
-              <a:t>• Anti-Tamper Policy: Permanent removal of re-attempt loops.</a:t>
-            </a:r>
-            <a:br/>
-            <a:br/>
-            <a:r>
-              <a:t>• Verified Printable Certificate: Immediate tamper-evident PDF download.</a:t>
+              <a:t>• Streamlined Verification: Direct authentication using Candidate Name, Email, and 6-Digit Room PIN.</a:t>
+            </a:r>
+            <a:br/>
+            <a:br/>
+            <a:r>
+              <a:t>• Synchronized Test Load: Instantly pulls and executes faculty-drafted exam questions.</a:t>
+            </a:r>
+            <a:br/>
+            <a:br/>
+            <a:r>
+              <a:t>• Anti-Cheat Perimeter: Displays active countdown timer and real-time strike warning counters.</a:t>
+            </a:r>
+            <a:br/>
+            <a:br/>
+            <a:r>
+              <a:t>• Verified Printable Certificate: One-click generation of official cryptographic PDF scorecards.</a:t>
+            </a:r>
+            <a:br/>
+            <a:br/>
+            <a:r>
+              <a:t>• Zero Retake Loophole: Exam submission locks the desk permanently to avoid multiple attempts.</a:t>
             </a:r>
           </a:p>
         </p:txBody>
@@ -4520,7 +4502,7 @@
             <a:avLst/>
           </a:prstGeom>
           <a:solidFill>
-            <a:srgbClr val="0B132B"/>
+            <a:srgbClr val="080D1A"/>
           </a:solidFill>
           <a:ln>
             <a:noFill/>
@@ -4581,19 +4563,19 @@
               </a:defRPr>
             </a:pPr>
             <a:r>
-              <a:t>SYSTEM FLOWCHART</a:t>
+              <a:t>WORKFLOW FLOWCHART</a:t>
             </a:r>
           </a:p>
           <a:p>
             <a:pPr>
-              <a:defRPr sz="2600" b="1">
+              <a:defRPr sz="2500" b="1">
                 <a:solidFill>
                   <a:srgbClr val="FFFFFF"/>
                 </a:solidFill>
               </a:defRPr>
             </a:pPr>
             <a:r>
-              <a:t>End-to-End Examination Execution Pipeline</a:t>
+              <a:t>End-to-End Exam Synchronization Flow</a:t>
             </a:r>
           </a:p>
         </p:txBody>
@@ -4606,14 +4588,14 @@
         </p:nvSpPr>
         <p:spPr>
           <a:xfrm>
-            <a:off x="731520" y="2103120"/>
-            <a:ext cx="2468880" cy="2194560"/>
+            <a:off x="731520" y="2011680"/>
+            <a:ext cx="2468880" cy="2286000"/>
           </a:xfrm>
           <a:prstGeom prst="roundRect">
             <a:avLst/>
           </a:prstGeom>
           <a:solidFill>
-            <a:srgbClr val="1C2541"/>
+            <a:srgbClr val="111827"/>
           </a:solidFill>
           <a:ln w="19050">
             <a:solidFill>
@@ -4643,14 +4625,14 @@
               <a:spcAft>
                 <a:spcPts val="600"/>
               </a:spcAft>
-              <a:defRPr sz="1400" b="1">
+              <a:defRPr sz="1300" b="1">
                 <a:solidFill>
                   <a:srgbClr val="38BDF8"/>
                 </a:solidFill>
               </a:defRPr>
             </a:pPr>
             <a:r>
-              <a:t>[FACULTY DRAFT]</a:t>
+              <a:t>FACULTY DRAFT</a:t>
             </a:r>
           </a:p>
           <a:p>
@@ -4658,18 +4640,22 @@
               <a:lnSpc>
                 <a:spcPct val="120000"/>
               </a:lnSpc>
-              <a:defRPr sz="1100">
+              <a:defRPr sz="1050">
                 <a:solidFill>
                   <a:srgbClr val="94A3B8"/>
                 </a:solidFill>
               </a:defRPr>
             </a:pPr>
             <a:r>
-              <a:t>Upload PDF Syllabus</a:t>
-            </a:r>
-            <a:br/>
-            <a:r>
-              <a:t>or Prompt Topic</a:t>
+              <a:t>Uploads syllabus PDF</a:t>
+            </a:r>
+            <a:br/>
+            <a:r>
+              <a:t>or inputs topic prompt</a:t>
+            </a:r>
+            <a:br/>
+            <a:r>
+              <a:t>AI builds questions</a:t>
             </a:r>
           </a:p>
         </p:txBody>
@@ -4682,14 +4668,14 @@
         </p:nvSpPr>
         <p:spPr>
           <a:xfrm>
-            <a:off x="1691640" y="1737360"/>
+            <a:off x="1691640" y="1645920"/>
             <a:ext cx="548640" cy="548640"/>
           </a:xfrm>
           <a:prstGeom prst="ellipse">
             <a:avLst/>
           </a:prstGeom>
           <a:solidFill>
-            <a:srgbClr val="A855F7"/>
+            <a:srgbClr val="2563EB"/>
           </a:solidFill>
           <a:ln>
             <a:noFill/>
@@ -4714,7 +4700,7 @@
           <a:lstStyle/>
           <a:p>
             <a:pPr algn="ctr">
-              <a:defRPr sz="1300" b="1">
+              <a:defRPr sz="1200" b="1">
                 <a:solidFill>
                   <a:srgbClr val="FFFFFF"/>
                 </a:solidFill>
@@ -4734,14 +4720,14 @@
         </p:nvSpPr>
         <p:spPr>
           <a:xfrm>
-            <a:off x="3474720" y="2103120"/>
-            <a:ext cx="2468880" cy="2194560"/>
+            <a:off x="3474720" y="2011680"/>
+            <a:ext cx="2468880" cy="2286000"/>
           </a:xfrm>
           <a:prstGeom prst="roundRect">
             <a:avLst/>
           </a:prstGeom>
           <a:solidFill>
-            <a:srgbClr val="1C2541"/>
+            <a:srgbClr val="111827"/>
           </a:solidFill>
           <a:ln w="19050">
             <a:solidFill>
@@ -4771,14 +4757,14 @@
               <a:spcAft>
                 <a:spcPts val="600"/>
               </a:spcAft>
-              <a:defRPr sz="1400" b="1">
+              <a:defRPr sz="1300" b="1">
                 <a:solidFill>
                   <a:srgbClr val="38BDF8"/>
                 </a:solidFill>
               </a:defRPr>
             </a:pPr>
             <a:r>
-              <a:t>[PIN BROADCAST]</a:t>
+              <a:t>PIN BROADCAST</a:t>
             </a:r>
           </a:p>
           <a:p>
@@ -4786,18 +4772,22 @@
               <a:lnSpc>
                 <a:spcPct val="120000"/>
               </a:lnSpc>
-              <a:defRPr sz="1100">
+              <a:defRPr sz="1050">
                 <a:solidFill>
                   <a:srgbClr val="94A3B8"/>
                 </a:solidFill>
               </a:defRPr>
             </a:pPr>
             <a:r>
-              <a:t>Engine launches room</a:t>
-            </a:r>
-            <a:br/>
-            <a:r>
-              <a:t>Generates 6-Digit PIN</a:t>
+              <a:t>Room launched;</a:t>
+            </a:r>
+            <a:br/>
+            <a:r>
+              <a:t>Unique 6-Digit PIN saved</a:t>
+            </a:r>
+            <a:br/>
+            <a:r>
+              <a:t>to shared room store</a:t>
             </a:r>
           </a:p>
         </p:txBody>
@@ -4810,14 +4800,14 @@
         </p:nvSpPr>
         <p:spPr>
           <a:xfrm>
-            <a:off x="4434840" y="1737360"/>
+            <a:off x="4434840" y="1645920"/>
             <a:ext cx="548640" cy="548640"/>
           </a:xfrm>
           <a:prstGeom prst="ellipse">
             <a:avLst/>
           </a:prstGeom>
           <a:solidFill>
-            <a:srgbClr val="A855F7"/>
+            <a:srgbClr val="2563EB"/>
           </a:solidFill>
           <a:ln>
             <a:noFill/>
@@ -4842,7 +4832,7 @@
           <a:lstStyle/>
           <a:p>
             <a:pPr algn="ctr">
-              <a:defRPr sz="1300" b="1">
+              <a:defRPr sz="1200" b="1">
                 <a:solidFill>
                   <a:srgbClr val="FFFFFF"/>
                 </a:solidFill>
@@ -4862,14 +4852,14 @@
         </p:nvSpPr>
         <p:spPr>
           <a:xfrm>
-            <a:off x="6217920" y="2103120"/>
-            <a:ext cx="2468880" cy="2194560"/>
+            <a:off x="6217920" y="2011680"/>
+            <a:ext cx="2468880" cy="2286000"/>
           </a:xfrm>
           <a:prstGeom prst="roundRect">
             <a:avLst/>
           </a:prstGeom>
           <a:solidFill>
-            <a:srgbClr val="1C2541"/>
+            <a:srgbClr val="111827"/>
           </a:solidFill>
           <a:ln w="19050">
             <a:solidFill>
@@ -4899,14 +4889,14 @@
               <a:spcAft>
                 <a:spcPts val="600"/>
               </a:spcAft>
-              <a:defRPr sz="1400" b="1">
+              <a:defRPr sz="1300" b="1">
                 <a:solidFill>
                   <a:srgbClr val="38BDF8"/>
                 </a:solidFill>
               </a:defRPr>
             </a:pPr>
             <a:r>
-              <a:t>[STUDENT ARENA]</a:t>
+              <a:t>STUDENT JOIN</a:t>
             </a:r>
           </a:p>
           <a:p>
@@ -4914,18 +4904,22 @@
               <a:lnSpc>
                 <a:spcPct val="120000"/>
               </a:lnSpc>
-              <a:defRPr sz="1100">
+              <a:defRPr sz="1050">
                 <a:solidFill>
                   <a:srgbClr val="94A3B8"/>
                 </a:solidFill>
               </a:defRPr>
             </a:pPr>
             <a:r>
-              <a:t>Student enters credentials</a:t>
-            </a:r>
-            <a:br/>
-            <a:r>
-              <a:t>&amp; loads active test</a:t>
+              <a:t>Candidate inputs details</a:t>
+            </a:r>
+            <a:br/>
+            <a:r>
+              <a:t>&amp; PIN; active questions</a:t>
+            </a:r>
+            <a:br/>
+            <a:r>
+              <a:t>loaded into exam arena</a:t>
             </a:r>
           </a:p>
         </p:txBody>
@@ -4938,14 +4932,14 @@
         </p:nvSpPr>
         <p:spPr>
           <a:xfrm>
-            <a:off x="7178040" y="1737360"/>
+            <a:off x="7178040" y="1645920"/>
             <a:ext cx="548640" cy="548640"/>
           </a:xfrm>
           <a:prstGeom prst="ellipse">
             <a:avLst/>
           </a:prstGeom>
           <a:solidFill>
-            <a:srgbClr val="A855F7"/>
+            <a:srgbClr val="2563EB"/>
           </a:solidFill>
           <a:ln>
             <a:noFill/>
@@ -4970,7 +4964,7 @@
           <a:lstStyle/>
           <a:p>
             <a:pPr algn="ctr">
-              <a:defRPr sz="1300" b="1">
+              <a:defRPr sz="1200" b="1">
                 <a:solidFill>
                   <a:srgbClr val="FFFFFF"/>
                 </a:solidFill>
@@ -4990,14 +4984,14 @@
         </p:nvSpPr>
         <p:spPr>
           <a:xfrm>
-            <a:off x="8961120" y="2103120"/>
-            <a:ext cx="2468880" cy="2194560"/>
+            <a:off x="8961120" y="2011680"/>
+            <a:ext cx="2468880" cy="2286000"/>
           </a:xfrm>
           <a:prstGeom prst="roundRect">
             <a:avLst/>
           </a:prstGeom>
           <a:solidFill>
-            <a:srgbClr val="1C2541"/>
+            <a:srgbClr val="111827"/>
           </a:solidFill>
           <a:ln w="19050">
             <a:solidFill>
@@ -5027,14 +5021,14 @@
               <a:spcAft>
                 <a:spcPts val="600"/>
               </a:spcAft>
-              <a:defRPr sz="1400" b="1">
+              <a:defRPr sz="1300" b="1">
                 <a:solidFill>
                   <a:srgbClr val="38BDF8"/>
                 </a:solidFill>
               </a:defRPr>
             </a:pPr>
             <a:r>
-              <a:t>[INTEGRITY &amp; LEDGER]</a:t>
+              <a:t>SUBMISSION</a:t>
             </a:r>
           </a:p>
           <a:p>
@@ -5042,18 +5036,22 @@
               <a:lnSpc>
                 <a:spcPct val="120000"/>
               </a:lnSpc>
-              <a:defRPr sz="1100">
+              <a:defRPr sz="1050">
                 <a:solidFill>
                   <a:srgbClr val="94A3B8"/>
                 </a:solidFill>
               </a:defRPr>
             </a:pPr>
             <a:r>
-              <a:t>Real-Time 3 Strikes &amp;</a:t>
-            </a:r>
-            <a:br/>
-            <a:r>
-              <a:t>Auto-Generated PDF</a:t>
+              <a:t>Proctor logs strikes;</a:t>
+            </a:r>
+            <a:br/>
+            <a:r>
+              <a:t>Score finalized;</a:t>
+            </a:r>
+            <a:br/>
+            <a:r>
+              <a:t>Verified PDF generated</a:t>
             </a:r>
           </a:p>
         </p:txBody>
@@ -5066,14 +5064,14 @@
         </p:nvSpPr>
         <p:spPr>
           <a:xfrm>
-            <a:off x="9921240" y="1737360"/>
+            <a:off x="9921240" y="1645920"/>
             <a:ext cx="548640" cy="548640"/>
           </a:xfrm>
           <a:prstGeom prst="ellipse">
             <a:avLst/>
           </a:prstGeom>
           <a:solidFill>
-            <a:srgbClr val="A855F7"/>
+            <a:srgbClr val="2563EB"/>
           </a:solidFill>
           <a:ln>
             <a:noFill/>
@@ -5098,7 +5096,7 @@
           <a:lstStyle/>
           <a:p>
             <a:pPr algn="ctr">
-              <a:defRPr sz="1300" b="1">
+              <a:defRPr sz="1200" b="1">
                 <a:solidFill>
                   <a:srgbClr val="FFFFFF"/>
                 </a:solidFill>
@@ -5247,18 +5245,18 @@
         </p:nvSpPr>
         <p:spPr>
           <a:xfrm>
-            <a:off x="731520" y="4754880"/>
-            <a:ext cx="10698480" cy="1371600"/>
+            <a:off x="731520" y="4663440"/>
+            <a:ext cx="10698480" cy="1463040"/>
           </a:xfrm>
           <a:prstGeom prst="roundRect">
             <a:avLst/>
           </a:prstGeom>
           <a:solidFill>
-            <a:srgbClr val="1C2541"/>
+            <a:srgbClr val="111827"/>
           </a:solidFill>
           <a:ln w="19050">
             <a:solidFill>
-              <a:srgbClr val="4F46E5"/>
+              <a:srgbClr val="2563EB"/>
             </a:solidFill>
           </a:ln>
         </p:spPr>
@@ -5284,14 +5282,14 @@
               <a:spcAft>
                 <a:spcPts val="600"/>
               </a:spcAft>
-              <a:defRPr sz="1400" b="1">
+              <a:defRPr sz="1300" b="1">
                 <a:solidFill>
                   <a:srgbClr val="38BDF8"/>
                 </a:solidFill>
               </a:defRPr>
             </a:pPr>
             <a:r>
-              <a:t>DATA PIPELINE INTEGRITY</a:t>
+              <a:t>DATA BUS ARCHITECTURE: REAL-TIME CLIENT-SIDE SYNCHRONIZATION</a:t>
             </a:r>
           </a:p>
           <a:p>
@@ -5299,14 +5297,22 @@
               <a:lnSpc>
                 <a:spcPct val="120000"/>
               </a:lnSpc>
-              <a:defRPr sz="1100">
+              <a:defRPr sz="1050">
                 <a:solidFill>
                   <a:srgbClr val="94A3B8"/>
                 </a:solidFill>
               </a:defRPr>
             </a:pPr>
             <a:r>
-              <a:t>localStorage room-store acts as the ultra-fast synchronized data bridge. Both teacher tracking and student submission update simultaneously without database overhead.</a:t>
+              <a:t>• Faculty and Student portals communicate through the standardized room-store bridge.</a:t>
+            </a:r>
+            <a:br/>
+            <a:r>
+              <a:t>• Student tab-switch events and strike increments update candidate records instantly.</a:t>
+            </a:r>
+            <a:br/>
+            <a:r>
+              <a:t>• Faculty Candidate Monitor polls updates every 2 seconds, displaying live progress and final marks without page refresh.</a:t>
             </a:r>
           </a:p>
         </p:txBody>
@@ -5344,7 +5350,7 @@
             <a:avLst/>
           </a:prstGeom>
           <a:solidFill>
-            <a:srgbClr val="0B132B"/>
+            <a:srgbClr val="080D1A"/>
           </a:solidFill>
           <a:ln>
             <a:noFill/>
@@ -5405,19 +5411,19 @@
               </a:defRPr>
             </a:pPr>
             <a:r>
-              <a:t>INTERFACE EXCELLENCE</a:t>
+              <a:t>SECURITY &amp; COMPLIANCE</a:t>
             </a:r>
           </a:p>
           <a:p>
             <a:pPr>
-              <a:defRPr sz="2600" b="1">
+              <a:defRPr sz="2500" b="1">
                 <a:solidFill>
                   <a:srgbClr val="FFFFFF"/>
                 </a:solidFill>
               </a:defRPr>
             </a:pPr>
             <a:r>
-              <a:t>High-Contrast UI &amp; Live Portal Showcase</a:t>
+              <a:t>Automated Behavioral Anti-Cheating Protocol</a:t>
             </a:r>
           </a:p>
         </p:txBody>
@@ -5431,17 +5437,17 @@
         <p:spPr>
           <a:xfrm>
             <a:off x="731520" y="1645920"/>
-            <a:ext cx="4114800" cy="4572000"/>
+            <a:ext cx="3291840" cy="4572000"/>
           </a:xfrm>
           <a:prstGeom prst="roundRect">
             <a:avLst/>
           </a:prstGeom>
           <a:solidFill>
-            <a:srgbClr val="1C2541"/>
+            <a:srgbClr val="111827"/>
           </a:solidFill>
           <a:ln w="19050">
             <a:solidFill>
-              <a:srgbClr val="4F46E5"/>
+              <a:srgbClr val="2563EB"/>
             </a:solidFill>
           </a:ln>
         </p:spPr>
@@ -5467,14 +5473,14 @@
               <a:spcAft>
                 <a:spcPts val="600"/>
               </a:spcAft>
-              <a:defRPr sz="1400" b="1">
+              <a:defRPr sz="1300" b="1">
                 <a:solidFill>
                   <a:srgbClr val="38BDF8"/>
                 </a:solidFill>
               </a:defRPr>
             </a:pPr>
             <a:r>
-              <a:t>CLEAN NETFLIX-GRADE UI</a:t>
+              <a:t>1. VISIBILITY DETECTION</a:t>
             </a:r>
           </a:p>
           <a:p>
@@ -5482,29 +5488,34 @@
               <a:lnSpc>
                 <a:spcPct val="120000"/>
               </a:lnSpc>
-              <a:defRPr sz="1100">
+              <a:defRPr sz="1050">
                 <a:solidFill>
                   <a:srgbClr val="94A3B8"/>
                 </a:solidFill>
               </a:defRPr>
             </a:pPr>
             <a:r>
-              <a:t>• Pure White Text (#FFFFFF) against Deep Void (#0B132B) for high clarity.</a:t>
-            </a:r>
-            <a:br/>
-            <a:br/>
-            <a:r>
-              <a:t>• Single Identity Focus: Removed confusing status capsules &amp; clutter.</a:t>
-            </a:r>
-            <a:br/>
-            <a:br/>
-            <a:r>
-              <a:t>• Instant Responsive Grids: Designed for mobile examinees and widescreen desktop faculty setups.</a:t>
-            </a:r>
-            <a:br/>
-            <a:br/>
-            <a:r>
-              <a:t>• Embedded Live Desk Frame on the right shows active proctored experience.</a:t>
+              <a:t>Leverages browser Document Visibility API.</a:t>
+            </a:r>
+            <a:br/>
+            <a:br/>
+            <a:r>
+              <a:t>• Instant detection when student tabs out</a:t>
+            </a:r>
+            <a:br/>
+            <a:br/>
+            <a:r>
+              <a:t>• Logs window minimization attempts</a:t>
+            </a:r>
+            <a:br/>
+            <a:br/>
+            <a:r>
+              <a:t>• Flags split-screen side tasks</a:t>
+            </a:r>
+            <a:br/>
+            <a:br/>
+            <a:r>
+              <a:t>• Works without intrusive camera requirements</a:t>
             </a:r>
           </a:p>
         </p:txBody>
@@ -5517,18 +5528,18 @@
         </p:nvSpPr>
         <p:spPr>
           <a:xfrm>
-            <a:off x="5120640" y="1645920"/>
-            <a:ext cx="6309360" cy="4572000"/>
+            <a:off x="4389120" y="1645920"/>
+            <a:ext cx="3291840" cy="4572000"/>
           </a:xfrm>
           <a:prstGeom prst="roundRect">
             <a:avLst/>
           </a:prstGeom>
           <a:solidFill>
-            <a:srgbClr val="0F172A"/>
+            <a:srgbClr val="111827"/>
           </a:solidFill>
-          <a:ln>
+          <a:ln w="19050">
             <a:solidFill>
-              <a:srgbClr val="4F46E5"/>
+              <a:srgbClr val="EF4444"/>
             </a:solidFill>
           </a:ln>
         </p:spPr>
@@ -5547,22 +5558,148 @@
           </a:fontRef>
         </p:style>
         <p:txBody>
-          <a:bodyPr rtlCol="0" anchor="ctr"/>
+          <a:bodyPr rtlCol="0" anchor="ctr" wrap="square" lIns="228600" rIns="228600" tIns="228600"/>
           <a:lstStyle/>
           <a:p>
             <a:pPr algn="ctr">
-              <a:defRPr sz="1200">
+              <a:spcAft>
+                <a:spcPts val="600"/>
+              </a:spcAft>
+              <a:defRPr sz="1300" b="1">
+                <a:solidFill>
+                  <a:srgbClr val="38BDF8"/>
+                </a:solidFill>
+              </a:defRPr>
+            </a:pPr>
+            <a:r>
+              <a:t>2. THE 3-STRIKE LADDER</a:t>
+            </a:r>
+          </a:p>
+          <a:p>
+            <a:pPr>
+              <a:lnSpc>
+                <a:spcPct val="120000"/>
+              </a:lnSpc>
+              <a:defRPr sz="1050">
                 <a:solidFill>
                   <a:srgbClr val="94A3B8"/>
                 </a:solidFill>
               </a:defRPr>
             </a:pPr>
             <a:r>
-              <a:t>LIVE DESK PREVIEW</a:t>
-            </a:r>
-            <a:br/>
-            <a:r>
-              <a:t>[Drop Screenshot Here]</a:t>
+              <a:t>Progressive disciplinary counter.</a:t>
+            </a:r>
+            <a:br/>
+            <a:br/>
+            <a:r>
+              <a:t>• Strike 1: Warning prompt on screen</a:t>
+            </a:r>
+            <a:br/>
+            <a:br/>
+            <a:r>
+              <a:t>• Strike 2: Severe violation penalty recorded</a:t>
+            </a:r>
+            <a:br/>
+            <a:br/>
+            <a:r>
+              <a:t>• Strike 3: AUTOMATIC TERMINATION</a:t>
+            </a:r>
+            <a:br/>
+            <a:br/>
+            <a:r>
+              <a:t>• Forces test auto-submission immediately</a:t>
+            </a:r>
+          </a:p>
+        </p:txBody>
+      </p:sp>
+      <p:sp>
+        <p:nvSpPr>
+          <p:cNvPr id="6" name="Rounded Rectangle 5"/>
+          <p:cNvSpPr/>
+          <p:nvPr/>
+        </p:nvSpPr>
+        <p:spPr>
+          <a:xfrm>
+            <a:off x="8046720" y="1645920"/>
+            <a:ext cx="3291840" cy="4572000"/>
+          </a:xfrm>
+          <a:prstGeom prst="roundRect">
+            <a:avLst/>
+          </a:prstGeom>
+          <a:solidFill>
+            <a:srgbClr val="111827"/>
+          </a:solidFill>
+          <a:ln w="19050">
+            <a:solidFill>
+              <a:srgbClr val="38BDF8"/>
+            </a:solidFill>
+          </a:ln>
+        </p:spPr>
+        <p:style>
+          <a:lnRef idx="1">
+            <a:schemeClr val="accent1"/>
+          </a:lnRef>
+          <a:fillRef idx="3">
+            <a:schemeClr val="accent1"/>
+          </a:fillRef>
+          <a:effectRef idx="2">
+            <a:schemeClr val="accent1"/>
+          </a:effectRef>
+          <a:fontRef idx="minor">
+            <a:schemeClr val="lt1"/>
+          </a:fontRef>
+        </p:style>
+        <p:txBody>
+          <a:bodyPr rtlCol="0" anchor="ctr" wrap="square" lIns="228600" rIns="228600" tIns="228600"/>
+          <a:lstStyle/>
+          <a:p>
+            <a:pPr algn="ctr">
+              <a:spcAft>
+                <a:spcPts val="600"/>
+              </a:spcAft>
+              <a:defRPr sz="1300" b="1">
+                <a:solidFill>
+                  <a:srgbClr val="38BDF8"/>
+                </a:solidFill>
+              </a:defRPr>
+            </a:pPr>
+            <a:r>
+              <a:t>3. PERMANENT LEDGER</a:t>
+            </a:r>
+          </a:p>
+          <a:p>
+            <a:pPr>
+              <a:lnSpc>
+                <a:spcPct val="120000"/>
+              </a:lnSpc>
+              <a:defRPr sz="1050">
+                <a:solidFill>
+                  <a:srgbClr val="94A3B8"/>
+                </a:solidFill>
+              </a:defRPr>
+            </a:pPr>
+            <a:r>
+              <a:t>Disciplinary action recorded in real time.</a:t>
+            </a:r>
+            <a:br/>
+            <a:br/>
+            <a:r>
+              <a:t>• Marked 'Disqualified (3 Strikes)' on dashboard</a:t>
+            </a:r>
+            <a:br/>
+            <a:br/>
+            <a:r>
+              <a:t>• PDF certificate stamped with violation tag</a:t>
+            </a:r>
+            <a:br/>
+            <a:br/>
+            <a:r>
+              <a:t>• Retake buttons removed permanently</a:t>
+            </a:r>
+            <a:br/>
+            <a:br/>
+            <a:r>
+              <a:t>• Faculty receives instant disqualified alert</a:t>
             </a:r>
           </a:p>
         </p:txBody>
@@ -5600,7 +5737,7 @@
             <a:avLst/>
           </a:prstGeom>
           <a:solidFill>
-            <a:srgbClr val="0B132B"/>
+            <a:srgbClr val="080D1A"/>
           </a:solidFill>
           <a:ln>
             <a:noFill/>
@@ -5661,19 +5798,19 @@
               </a:defRPr>
             </a:pPr>
             <a:r>
-              <a:t>EXAM SECURITY</a:t>
+              <a:t>PROJECT ROADMAP</a:t>
             </a:r>
           </a:p>
           <a:p>
             <a:pPr>
-              <a:defRPr sz="2600" b="1">
+              <a:defRPr sz="2500" b="1">
                 <a:solidFill>
                   <a:srgbClr val="FFFFFF"/>
                 </a:solidFill>
               </a:defRPr>
             </a:pPr>
             <a:r>
-              <a:t>Automated Behavioral Proctoring Shield</a:t>
+              <a:t>Future Roadmap &amp; Project Conclusion</a:t>
             </a:r>
           </a:p>
         </p:txBody>
@@ -5693,11 +5830,11 @@
             <a:avLst/>
           </a:prstGeom>
           <a:solidFill>
-            <a:srgbClr val="1C2541"/>
+            <a:srgbClr val="111827"/>
           </a:solidFill>
           <a:ln w="19050">
             <a:solidFill>
-              <a:srgbClr val="4F46E5"/>
+              <a:srgbClr val="2563EB"/>
             </a:solidFill>
           </a:ln>
         </p:spPr>
@@ -5723,14 +5860,14 @@
               <a:spcAft>
                 <a:spcPts val="600"/>
               </a:spcAft>
-              <a:defRPr sz="1400" b="1">
+              <a:defRPr sz="1300" b="1">
                 <a:solidFill>
                   <a:srgbClr val="38BDF8"/>
                 </a:solidFill>
               </a:defRPr>
             </a:pPr>
             <a:r>
-              <a:t>1. TAB VISIBILITY DETECT</a:t>
+              <a:t>PHASE 1: AUTH &amp; ROLES</a:t>
             </a:r>
           </a:p>
           <a:p>
@@ -5738,31 +5875,29 @@
               <a:lnSpc>
                 <a:spcPct val="120000"/>
               </a:lnSpc>
-              <a:defRPr sz="1100">
+              <a:defRPr sz="1050">
                 <a:solidFill>
                   <a:srgbClr val="94A3B8"/>
                 </a:solidFill>
               </a:defRPr>
             </a:pPr>
             <a:r>
-              <a:t>Harnesses HTML5 Page Visibility API.</a:t>
-            </a:r>
-            <a:br/>
-            <a:br/>
-            <a:r>
-              <a:t>• Instant detection of Alt+Tab</a:t>
-            </a:r>
-            <a:br/>
-            <a:r>
-              <a:t>• Tracks split-screen maneuvers</a:t>
-            </a:r>
-            <a:br/>
-            <a:r>
-              <a:t>• Detects minimized windows</a:t>
-            </a:r>
-            <a:br/>
-            <a:r>
-              <a:t>• Real-time logging of violations</a:t>
+              <a:t>• Super-Admin Command Panel (/admin)</a:t>
+            </a:r>
+            <a:br/>
+            <a:br/>
+            <a:r>
+              <a:t>• Centralized Faculty approval workflow</a:t>
+            </a:r>
+            <a:br/>
+            <a:br/>
+            <a:r>
+              <a:t>• Telegram/Email registration webhook alerts</a:t>
+            </a:r>
+            <a:br/>
+            <a:br/>
+            <a:r>
+              <a:t>• Institutional multi-tenant support</a:t>
             </a:r>
           </a:p>
         </p:txBody>
@@ -5782,11 +5917,11 @@
             <a:avLst/>
           </a:prstGeom>
           <a:solidFill>
-            <a:srgbClr val="1C2541"/>
+            <a:srgbClr val="111827"/>
           </a:solidFill>
           <a:ln w="19050">
             <a:solidFill>
-              <a:srgbClr val="F43F5E"/>
+              <a:srgbClr val="2563EB"/>
             </a:solidFill>
           </a:ln>
         </p:spPr>
@@ -5812,14 +5947,14 @@
               <a:spcAft>
                 <a:spcPts val="600"/>
               </a:spcAft>
-              <a:defRPr sz="1400" b="1">
+              <a:defRPr sz="1300" b="1">
                 <a:solidFill>
                   <a:srgbClr val="38BDF8"/>
                 </a:solidFill>
               </a:defRPr>
             </a:pPr>
             <a:r>
-              <a:t>2. THE 3-STRIKE PENALTY</a:t>
+              <a:t>PHASE 2: AI AUDIT</a:t>
             </a:r>
           </a:p>
           <a:p>
@@ -5827,31 +5962,29 @@
               <a:lnSpc>
                 <a:spcPct val="120000"/>
               </a:lnSpc>
-              <a:defRPr sz="1100">
+              <a:defRPr sz="1050">
                 <a:solidFill>
                   <a:srgbClr val="94A3B8"/>
                 </a:solidFill>
               </a:defRPr>
             </a:pPr>
             <a:r>
-              <a:t>Direct progressive warning system.</a:t>
-            </a:r>
-            <a:br/>
-            <a:br/>
-            <a:r>
-              <a:t>• Strike 1: Notice alert on screen</a:t>
-            </a:r>
-            <a:br/>
-            <a:r>
-              <a:t>• Strike 2: Severe violation penalty</a:t>
-            </a:r>
-            <a:br/>
-            <a:r>
-              <a:t>• Strike 3: AUTOMATIC SUBMIT</a:t>
-            </a:r>
-            <a:br/>
-            <a:r>
-              <a:t>• Prevents candidate tampering</a:t>
+              <a:t>• Computer vision eye-tracking algorithms</a:t>
+            </a:r>
+            <a:br/>
+            <a:br/>
+            <a:r>
+              <a:t>• Background ambient noise analysis</a:t>
+            </a:r>
+            <a:br/>
+            <a:br/>
+            <a:r>
+              <a:t>• Direct SMTP scorecard email dispatch</a:t>
+            </a:r>
+            <a:br/>
+            <a:br/>
+            <a:r>
+              <a:t>• LMS connectors (Canvas &amp; Google Classroom)</a:t>
             </a:r>
           </a:p>
         </p:txBody>
@@ -5871,375 +6004,7 @@
             <a:avLst/>
           </a:prstGeom>
           <a:solidFill>
-            <a:srgbClr val="1C2541"/>
-          </a:solidFill>
-          <a:ln w="19050">
-            <a:solidFill>
-              <a:srgbClr val="A855F7"/>
-            </a:solidFill>
-          </a:ln>
-        </p:spPr>
-        <p:style>
-          <a:lnRef idx="1">
-            <a:schemeClr val="accent1"/>
-          </a:lnRef>
-          <a:fillRef idx="3">
-            <a:schemeClr val="accent1"/>
-          </a:fillRef>
-          <a:effectRef idx="2">
-            <a:schemeClr val="accent1"/>
-          </a:effectRef>
-          <a:fontRef idx="minor">
-            <a:schemeClr val="lt1"/>
-          </a:fontRef>
-        </p:style>
-        <p:txBody>
-          <a:bodyPr rtlCol="0" anchor="ctr" wrap="square" lIns="228600" rIns="228600" tIns="228600"/>
-          <a:lstStyle/>
-          <a:p>
-            <a:pPr algn="ctr">
-              <a:spcAft>
-                <a:spcPts val="600"/>
-              </a:spcAft>
-              <a:defRPr sz="1400" b="1">
-                <a:solidFill>
-                  <a:srgbClr val="38BDF8"/>
-                </a:solidFill>
-              </a:defRPr>
-            </a:pPr>
-            <a:r>
-              <a:t>3. EXPULSION &amp; LEDGER</a:t>
-            </a:r>
-          </a:p>
-          <a:p>
-            <a:pPr>
-              <a:lnSpc>
-                <a:spcPct val="120000"/>
-              </a:lnSpc>
-              <a:defRPr sz="1100">
-                <a:solidFill>
-                  <a:srgbClr val="94A3B8"/>
-                </a:solidFill>
-              </a:defRPr>
-            </a:pPr>
-            <a:r>
-              <a:t>Candidate ledger permanently updated.</a:t>
-            </a:r>
-            <a:br/>
-            <a:br/>
-            <a:r>
-              <a:t>• Flagged as 'Disqualified (3 Strikes)'</a:t>
-            </a:r>
-            <a:br/>
-            <a:r>
-              <a:t>• Faculty monitor updates live</a:t>
-            </a:r>
-            <a:br/>
-            <a:r>
-              <a:t>• Scorecard stamps disciplinary mark</a:t>
-            </a:r>
-            <a:br/>
-            <a:r>
-              <a:t>• Retake option locked down</a:t>
-            </a:r>
-          </a:p>
-        </p:txBody>
-      </p:sp>
-    </p:spTree>
-  </p:cSld>
-  <p:clrMapOvr>
-    <a:masterClrMapping/>
-  </p:clrMapOvr>
-</p:sld>
-</file>
-
-<file path=ppt/slides/slide8.xml><?xml version="1.0" encoding="utf-8"?>
-<p:sld xmlns:a="http://schemas.openxmlformats.org/drawingml/2006/main" xmlns:p="http://schemas.openxmlformats.org/presentationml/2006/main" xmlns:r="http://schemas.openxmlformats.org/officeDocument/2006/relationships">
-  <p:cSld>
-    <p:spTree>
-      <p:nvGrpSpPr>
-        <p:cNvPr id="1" name=""/>
-        <p:cNvGrpSpPr/>
-        <p:nvPr/>
-      </p:nvGrpSpPr>
-      <p:grpSpPr/>
-      <p:sp>
-        <p:nvSpPr>
-          <p:cNvPr id="2" name="Rectangle 1"/>
-          <p:cNvSpPr/>
-          <p:nvPr/>
-        </p:nvSpPr>
-        <p:spPr>
-          <a:xfrm>
-            <a:off x="0" y="0"/>
-            <a:ext cx="12191695" cy="6858000"/>
-          </a:xfrm>
-          <a:prstGeom prst="rect">
-            <a:avLst/>
-          </a:prstGeom>
-          <a:solidFill>
-            <a:srgbClr val="0B132B"/>
-          </a:solidFill>
-          <a:ln>
-            <a:noFill/>
-          </a:ln>
-        </p:spPr>
-        <p:style>
-          <a:lnRef idx="1">
-            <a:schemeClr val="accent1"/>
-          </a:lnRef>
-          <a:fillRef idx="3">
-            <a:schemeClr val="accent1"/>
-          </a:fillRef>
-          <a:effectRef idx="2">
-            <a:schemeClr val="accent1"/>
-          </a:effectRef>
-          <a:fontRef idx="minor">
-            <a:schemeClr val="lt1"/>
-          </a:fontRef>
-        </p:style>
-        <p:txBody>
-          <a:bodyPr rtlCol="0" anchor="ctr"/>
-          <a:lstStyle/>
-          <a:p>
-            <a:pPr algn="ctr"/>
-          </a:p>
-        </p:txBody>
-      </p:sp>
-      <p:sp>
-        <p:nvSpPr>
-          <p:cNvPr id="3" name="TextBox 2"/>
-          <p:cNvSpPr txBox="1"/>
-          <p:nvPr/>
-        </p:nvSpPr>
-        <p:spPr>
-          <a:xfrm>
-            <a:off x="731520" y="365760"/>
-            <a:ext cx="10698480" cy="1005840"/>
-          </a:xfrm>
-          <a:prstGeom prst="rect">
-            <a:avLst/>
-          </a:prstGeom>
-          <a:noFill/>
-        </p:spPr>
-        <p:txBody>
-          <a:bodyPr wrap="square">
-            <a:spAutoFit/>
-          </a:bodyPr>
-          <a:lstStyle/>
-          <a:p>
-            <a:pPr>
-              <a:spcAft>
-                <a:spcPts val="200"/>
-              </a:spcAft>
-              <a:defRPr sz="1000" b="1">
-                <a:solidFill>
-                  <a:srgbClr val="38BDF8"/>
-                </a:solidFill>
-              </a:defRPr>
-            </a:pPr>
-            <a:r>
-              <a:t>WHAT'S NEXT</a:t>
-            </a:r>
-          </a:p>
-          <a:p>
-            <a:pPr>
-              <a:defRPr sz="2600" b="1">
-                <a:solidFill>
-                  <a:srgbClr val="FFFFFF"/>
-                </a:solidFill>
-              </a:defRPr>
-            </a:pPr>
-            <a:r>
-              <a:t>Future Evolution &amp; Project Conclusion</a:t>
-            </a:r>
-          </a:p>
-        </p:txBody>
-      </p:sp>
-      <p:sp>
-        <p:nvSpPr>
-          <p:cNvPr id="4" name="Rounded Rectangle 3"/>
-          <p:cNvSpPr/>
-          <p:nvPr/>
-        </p:nvSpPr>
-        <p:spPr>
-          <a:xfrm>
-            <a:off x="731520" y="1645920"/>
-            <a:ext cx="3291840" cy="4572000"/>
-          </a:xfrm>
-          <a:prstGeom prst="roundRect">
-            <a:avLst/>
-          </a:prstGeom>
-          <a:solidFill>
-            <a:srgbClr val="1C2541"/>
-          </a:solidFill>
-          <a:ln w="19050">
-            <a:solidFill>
-              <a:srgbClr val="4F46E5"/>
-            </a:solidFill>
-          </a:ln>
-        </p:spPr>
-        <p:style>
-          <a:lnRef idx="1">
-            <a:schemeClr val="accent1"/>
-          </a:lnRef>
-          <a:fillRef idx="3">
-            <a:schemeClr val="accent1"/>
-          </a:fillRef>
-          <a:effectRef idx="2">
-            <a:schemeClr val="accent1"/>
-          </a:effectRef>
-          <a:fontRef idx="minor">
-            <a:schemeClr val="lt1"/>
-          </a:fontRef>
-        </p:style>
-        <p:txBody>
-          <a:bodyPr rtlCol="0" anchor="ctr" wrap="square" lIns="228600" rIns="228600" tIns="228600"/>
-          <a:lstStyle/>
-          <a:p>
-            <a:pPr algn="ctr">
-              <a:spcAft>
-                <a:spcPts val="600"/>
-              </a:spcAft>
-              <a:defRPr sz="1400" b="1">
-                <a:solidFill>
-                  <a:srgbClr val="38BDF8"/>
-                </a:solidFill>
-              </a:defRPr>
-            </a:pPr>
-            <a:r>
-              <a:t>PHASE 1: COMPUTER VISION</a:t>
-            </a:r>
-          </a:p>
-          <a:p>
-            <a:pPr>
-              <a:lnSpc>
-                <a:spcPct val="120000"/>
-              </a:lnSpc>
-              <a:defRPr sz="1100">
-                <a:solidFill>
-                  <a:srgbClr val="94A3B8"/>
-                </a:solidFill>
-              </a:defRPr>
-            </a:pPr>
-            <a:r>
-              <a:t>• Browser Webcam Eye Tracking</a:t>
-            </a:r>
-            <a:br/>
-            <a:r>
-              <a:t>• Multi-face detection alerts</a:t>
-            </a:r>
-            <a:br/>
-            <a:r>
-              <a:t>• Background noise audio analysis</a:t>
-            </a:r>
-            <a:br/>
-            <a:r>
-              <a:t>• AI-driven head pose estimation</a:t>
-            </a:r>
-          </a:p>
-        </p:txBody>
-      </p:sp>
-      <p:sp>
-        <p:nvSpPr>
-          <p:cNvPr id="5" name="Rounded Rectangle 4"/>
-          <p:cNvSpPr/>
-          <p:nvPr/>
-        </p:nvSpPr>
-        <p:spPr>
-          <a:xfrm>
-            <a:off x="4389120" y="1645920"/>
-            <a:ext cx="3291840" cy="4572000"/>
-          </a:xfrm>
-          <a:prstGeom prst="roundRect">
-            <a:avLst/>
-          </a:prstGeom>
-          <a:solidFill>
-            <a:srgbClr val="1C2541"/>
-          </a:solidFill>
-          <a:ln w="19050">
-            <a:solidFill>
-              <a:srgbClr val="4F46E5"/>
-            </a:solidFill>
-          </a:ln>
-        </p:spPr>
-        <p:style>
-          <a:lnRef idx="1">
-            <a:schemeClr val="accent1"/>
-          </a:lnRef>
-          <a:fillRef idx="3">
-            <a:schemeClr val="accent1"/>
-          </a:fillRef>
-          <a:effectRef idx="2">
-            <a:schemeClr val="accent1"/>
-          </a:effectRef>
-          <a:fontRef idx="minor">
-            <a:schemeClr val="lt1"/>
-          </a:fontRef>
-        </p:style>
-        <p:txBody>
-          <a:bodyPr rtlCol="0" anchor="ctr" wrap="square" lIns="228600" rIns="228600" tIns="228600"/>
-          <a:lstStyle/>
-          <a:p>
-            <a:pPr algn="ctr">
-              <a:spcAft>
-                <a:spcPts val="600"/>
-              </a:spcAft>
-              <a:defRPr sz="1400" b="1">
-                <a:solidFill>
-                  <a:srgbClr val="38BDF8"/>
-                </a:solidFill>
-              </a:defRPr>
-            </a:pPr>
-            <a:r>
-              <a:t>PHASE 2: CLOUD &amp; LMS</a:t>
-            </a:r>
-          </a:p>
-          <a:p>
-            <a:pPr>
-              <a:lnSpc>
-                <a:spcPct val="120000"/>
-              </a:lnSpc>
-              <a:defRPr sz="1100">
-                <a:solidFill>
-                  <a:srgbClr val="94A3B8"/>
-                </a:solidFill>
-              </a:defRPr>
-            </a:pPr>
-            <a:r>
-              <a:t>• Supabase/Firebase persistent sync</a:t>
-            </a:r>
-            <a:br/>
-            <a:r>
-              <a:t>• Google Classroom integration</a:t>
-            </a:r>
-            <a:br/>
-            <a:r>
-              <a:t>• Automated SMTP score mailer</a:t>
-            </a:r>
-            <a:br/>
-            <a:r>
-              <a:t>• Student performance analytics</a:t>
-            </a:r>
-          </a:p>
-        </p:txBody>
-      </p:sp>
-      <p:sp>
-        <p:nvSpPr>
-          <p:cNvPr id="6" name="Rounded Rectangle 5"/>
-          <p:cNvSpPr/>
-          <p:nvPr/>
-        </p:nvSpPr>
-        <p:spPr>
-          <a:xfrm>
-            <a:off x="8046720" y="1645920"/>
-            <a:ext cx="3291840" cy="4572000"/>
-          </a:xfrm>
-          <a:prstGeom prst="roundRect">
-            <a:avLst/>
-          </a:prstGeom>
-          <a:solidFill>
-            <a:srgbClr val="1C2541"/>
+            <a:srgbClr val="111827"/>
           </a:solidFill>
           <a:ln w="19050">
             <a:solidFill>
@@ -6269,14 +6034,14 @@
               <a:spcAft>
                 <a:spcPts val="600"/>
               </a:spcAft>
-              <a:defRPr sz="1400" b="1">
+              <a:defRPr sz="1300" b="1">
                 <a:solidFill>
                   <a:srgbClr val="38BDF8"/>
                 </a:solidFill>
               </a:defRPr>
             </a:pPr>
             <a:r>
-              <a:t>PROJECT WRAP-UP</a:t>
+              <a:t>SUMMARY &amp; IMPACT</a:t>
             </a:r>
           </a:p>
           <a:p>
@@ -6284,19 +6049,23 @@
               <a:lnSpc>
                 <a:spcPct val="120000"/>
               </a:lnSpc>
-              <a:defRPr sz="1100">
+              <a:defRPr sz="1050">
                 <a:solidFill>
                   <a:srgbClr val="94A3B8"/>
                 </a:solidFill>
               </a:defRPr>
             </a:pPr>
             <a:r>
-              <a:t>THE BIG CLASSES delivers a solid, tamper-resistant assessment ecosystem.</a:t>
-            </a:r>
-            <a:br/>
-            <a:br/>
-            <a:r>
-              <a:t>Developed with focus on speed, design precision, and academic integrity.</a:t>
+              <a:t>THE BIG CLASSES provides an academic examination ecosystem that bridges speed, proctoring security, and design clarity.</a:t>
+            </a:r>
+            <a:br/>
+            <a:br/>
+            <a:r>
+              <a:t>• Live on Vercel &amp; GitHub</a:t>
+            </a:r>
+            <a:br/>
+            <a:r>
+              <a:t>• Zero Cheating Tolerance</a:t>
             </a:r>
             <a:br/>
             <a:br/>

</xml_diff>